<commit_message>
fix(presentation): replace lifted sample metrics with fictional values
</commit_message>
<xml_diff>
--- a/packages/desktop/resources/presentation-templates/connected-ops.pptx
+++ b/packages/desktop/resources/presentation-templates/connected-ops.pptx
@@ -5,14 +5,14 @@
     <p:sldMasterId xmlns:r="http://schemas.openxmlformats.org/officeDocument/2006/relationships" id="2147483648" r:id="rId1"/>
   </p:sldMasterIdLst>
   <p:sldIdLst>
-    <p:sldId id="256" r:id="R41224c19d0ae4fd6"/>
-    <p:sldId id="257" r:id="Rad461615e3f94c80"/>
-    <p:sldId id="258" r:id="R84165441c8e24cea"/>
-    <p:sldId id="259" r:id="R200940358585408c"/>
-    <p:sldId id="260" r:id="R10343a9bb6f04a93"/>
-    <p:sldId id="261" r:id="R67ee7a469b4d4ea7"/>
-    <p:sldId id="262" r:id="Rbfb0fe1f74574e53"/>
-    <p:sldId id="263" r:id="R32c0ace3348244df"/>
+    <p:sldId id="256" r:id="R74cf3bf7e16c4ee2"/>
+    <p:sldId id="257" r:id="R57505964b7be475c"/>
+    <p:sldId id="258" r:id="Rfcdcc7b36fd14a10"/>
+    <p:sldId id="259" r:id="R2a711eb92bc74ee7"/>
+    <p:sldId id="260" r:id="Rb5eb9becc17a4b15"/>
+    <p:sldId id="261" r:id="R3a78745fd4614e91"/>
+    <p:sldId id="262" r:id="R0d203d85d0524f6b"/>
+    <p:sldId id="263" r:id="Rd1ab87a58c39431c"/>
   </p:sldIdLst>
   <p:sldSz cx="12192000" cy="6858000"/>
   <p:notesSz cx="6858000" cy="9144000"/>
@@ -1565,7 +1565,7 @@
                 <a:latin typeface="Calibri"/>
                 <a:ea typeface="Calibri"/>
               </a:rPr>
-              <a:t>68</a:t>
+              <a:t>47</a:t>
             </a:r>
           </a:p>
         </p:txBody>
@@ -1608,7 +1608,7 @@
       </p:sp>
       <p:sp>
         <p:nvSpPr>
-          <p:cNvPr id="100023" name="Pill_Globalusecases"/>
+          <p:cNvPr id="100023" name="Pill_Activeusecases"/>
           <p:cNvSpPr/>
           <p:nvPr/>
         </p:nvSpPr>
@@ -1691,7 +1691,7 @@
                 <a:latin typeface="Calibri"/>
                 <a:ea typeface="Calibri"/>
               </a:rPr>
-              <a:t>85</a:t>
+              <a:t>31</a:t>
             </a:r>
           </a:p>
         </p:txBody>
@@ -1727,7 +1727,7 @@
                 <a:latin typeface="Calibri"/>
                 <a:ea typeface="Calibri"/>
               </a:rPr>
-              <a:t>Global use cases</a:t>
+              <a:t>Active use cases</a:t>
             </a:r>
           </a:p>
         </p:txBody>
@@ -1817,7 +1817,7 @@
                 <a:latin typeface="Calibri"/>
                 <a:ea typeface="Calibri"/>
               </a:rPr>
-              <a:t>20,000+</a:t>
+              <a:t>5,400+</a:t>
             </a:r>
           </a:p>
         </p:txBody>
@@ -1943,7 +1943,7 @@
                 <a:latin typeface="Calibri"/>
                 <a:ea typeface="Calibri"/>
               </a:rPr>
-              <a:t>3,499</a:t>
+              <a:t>1,180</a:t>
             </a:r>
           </a:p>
         </p:txBody>
@@ -1986,7 +1986,7 @@
       </p:sp>
       <p:sp>
         <p:nvSpPr>
-          <p:cNvPr id="100035" name="Pill_Sitesonrollout"/>
+          <p:cNvPr id="100035" name="Pill_Sitesinrollout"/>
           <p:cNvSpPr/>
           <p:nvPr/>
         </p:nvSpPr>
@@ -2069,7 +2069,7 @@
                 <a:latin typeface="Calibri"/>
                 <a:ea typeface="Calibri"/>
               </a:rPr>
-              <a:t>144</a:t>
+              <a:t>52</a:t>
             </a:r>
           </a:p>
         </p:txBody>
@@ -2105,7 +2105,7 @@
                 <a:latin typeface="Calibri"/>
                 <a:ea typeface="Calibri"/>
               </a:rPr>
-              <a:t>Sites on rollout</a:t>
+              <a:t>Sites in rollout</a:t>
             </a:r>
           </a:p>
         </p:txBody>
@@ -2195,7 +2195,7 @@
                 <a:latin typeface="Calibri"/>
                 <a:ea typeface="Calibri"/>
               </a:rPr>
-              <a:t>225k</a:t>
+              <a:t>90k</a:t>
             </a:r>
           </a:p>
         </p:txBody>
@@ -2321,7 +2321,7 @@
                 <a:latin typeface="Calibri"/>
                 <a:ea typeface="Calibri"/>
               </a:rPr>
-              <a:t>62</a:t>
+              <a:t>14</a:t>
             </a:r>
           </a:p>
         </p:txBody>

</xml_diff>